<commit_message>
feat: converge semantic layout compiler
</commit_message>
<xml_diff>
--- a/go-backend/internal/generation/assets/system-default-template.pptx
+++ b/go-backend/internal/generation/assets/system-default-template.pptx
@@ -6,6 +6,11 @@
   </p:sldMasterIdLst>
   <p:sldIdLst>
     <p:sldId id="256" r:id="rId7"/>
+    <p:sldId id="257" r:id="rId8"/>
+    <p:sldId id="258" r:id="rId9"/>
+    <p:sldId id="259" r:id="rId10"/>
+    <p:sldId id="260" r:id="rId11"/>
+    <p:sldId id="261" r:id="rId12"/>
   </p:sldIdLst>
   <p:sldSz cx="12192000" cy="6858000" type="screen4x3"/>
   <p:notesSz cx="6858000" cy="9144000"/>
@@ -3090,14 +3095,14 @@
       <p:grpSpPr/>
       <p:sp>
         <p:nvSpPr>
-          <p:cNvPr id="2" name="TextBox 1"/>
+          <p:cNvPr id="2" name="系统默认TITLE1"/>
           <p:cNvSpPr txBox="1"/>
           <p:nvPr/>
         </p:nvSpPr>
         <p:spPr>
           <a:xfrm>
-            <a:off x="350000" y="350000"/>
-            <a:ext cx="1450000" cy="600000"/>
+            <a:off x="650000" y="400000"/>
+            <a:ext cx="10800000" cy="850000"/>
           </a:xfrm>
           <a:prstGeom prst="rect">
             <a:avLst/>
@@ -3105,14 +3110,14 @@
           <a:noFill/>
         </p:spPr>
         <p:txBody>
-          <a:bodyPr wrap="none">
-            <a:spAutoFit/>
+          <a:bodyPr wrap="square">
+            <a:normAutofit/>
           </a:bodyPr>
           <a:lstStyle/>
           <a:p>
             <a:pPr algn="l"/>
             <a:r>
-              <a:rPr sz="1600">
+              <a:rPr sz="2800">
                 <a:latin typeface="Microsoft YaHei"/>
               </a:rPr>
               <a:t>系统默认内容</a:t>
@@ -3122,14 +3127,14 @@
       </p:sp>
       <p:sp>
         <p:nvSpPr>
-          <p:cNvPr id="3" name="TextBox 2"/>
+          <p:cNvPr id="3" name="系统默认BULLETS2"/>
           <p:cNvSpPr txBox="1"/>
           <p:nvPr/>
         </p:nvSpPr>
         <p:spPr>
           <a:xfrm>
-            <a:off x="2050000" y="350000"/>
-            <a:ext cx="1450000" cy="600000"/>
+            <a:off x="6000000" y="1550000"/>
+            <a:ext cx="5350000" cy="4400000"/>
           </a:xfrm>
           <a:prstGeom prst="rect">
             <a:avLst/>
@@ -3137,14 +3142,14 @@
           <a:noFill/>
         </p:spPr>
         <p:txBody>
-          <a:bodyPr wrap="none">
-            <a:spAutoFit/>
+          <a:bodyPr wrap="square">
+            <a:normAutofit/>
           </a:bodyPr>
           <a:lstStyle/>
           <a:p>
             <a:pPr algn="l"/>
             <a:r>
-              <a:rPr sz="1600">
+              <a:rPr sz="1800">
                 <a:latin typeface="Microsoft YaHei"/>
               </a:rPr>
               <a:t>系统默认内容</a:t>
@@ -3152,16 +3157,34 @@
           </a:p>
         </p:txBody>
       </p:sp>
-      <p:sp>
-        <p:nvSpPr>
-          <p:cNvPr id="4" name="TextBox 3"/>
+    </p:spTree>
+  </p:cSld>
+  <p:clrMapOvr>
+    <a:masterClrMapping/>
+  </p:clrMapOvr>
+</p:sld>
+</file>
+
+<file path=ppt/slides/slide2.xml><?xml version="1.0" encoding="utf-8"?>
+<p:sld xmlns:a="http://schemas.openxmlformats.org/drawingml/2006/main" xmlns:p="http://schemas.openxmlformats.org/presentationml/2006/main" xmlns:r="http://schemas.openxmlformats.org/officeDocument/2006/relationships">
+  <p:cSld>
+    <p:spTree>
+      <p:nvGrpSpPr>
+        <p:cNvPr id="1" name=""/>
+        <p:cNvGrpSpPr/>
+        <p:nvPr/>
+      </p:nvGrpSpPr>
+      <p:grpSpPr/>
+      <p:sp>
+        <p:nvSpPr>
+          <p:cNvPr id="2" name="系统默认TITLE1"/>
           <p:cNvSpPr txBox="1"/>
           <p:nvPr/>
         </p:nvSpPr>
         <p:spPr>
           <a:xfrm>
-            <a:off x="3750000" y="350000"/>
-            <a:ext cx="1450000" cy="600000"/>
+            <a:off x="650000" y="400000"/>
+            <a:ext cx="10800000" cy="850000"/>
           </a:xfrm>
           <a:prstGeom prst="rect">
             <a:avLst/>
@@ -3169,14 +3192,14 @@
           <a:noFill/>
         </p:spPr>
         <p:txBody>
-          <a:bodyPr wrap="none">
-            <a:spAutoFit/>
+          <a:bodyPr wrap="square">
+            <a:normAutofit/>
           </a:bodyPr>
           <a:lstStyle/>
           <a:p>
             <a:pPr algn="l"/>
             <a:r>
-              <a:rPr sz="1600">
+              <a:rPr sz="2800">
                 <a:latin typeface="Microsoft YaHei"/>
               </a:rPr>
               <a:t>系统默认内容</a:t>
@@ -3186,14 +3209,14 @@
       </p:sp>
       <p:sp>
         <p:nvSpPr>
-          <p:cNvPr id="5" name="TextBox 4"/>
+          <p:cNvPr id="3" name="系统默认BODY2"/>
           <p:cNvSpPr txBox="1"/>
           <p:nvPr/>
         </p:nvSpPr>
         <p:spPr>
           <a:xfrm>
-            <a:off x="5450000" y="350000"/>
-            <a:ext cx="1450000" cy="600000"/>
+            <a:off x="750000" y="1550000"/>
+            <a:ext cx="4900000" cy="4000000"/>
           </a:xfrm>
           <a:prstGeom prst="rect">
             <a:avLst/>
@@ -3201,14 +3224,14 @@
           <a:noFill/>
         </p:spPr>
         <p:txBody>
-          <a:bodyPr wrap="none">
-            <a:spAutoFit/>
+          <a:bodyPr wrap="square">
+            <a:normAutofit/>
           </a:bodyPr>
           <a:lstStyle/>
           <a:p>
             <a:pPr algn="l"/>
             <a:r>
-              <a:rPr sz="1600">
+              <a:rPr sz="1800">
                 <a:latin typeface="Microsoft YaHei"/>
               </a:rPr>
               <a:t>系统默认内容</a:t>
@@ -3218,14 +3241,14 @@
       </p:sp>
       <p:sp>
         <p:nvSpPr>
-          <p:cNvPr id="6" name="TextBox 5"/>
+          <p:cNvPr id="4" name="系统默认BULLETS3"/>
           <p:cNvSpPr txBox="1"/>
           <p:nvPr/>
         </p:nvSpPr>
         <p:spPr>
           <a:xfrm>
-            <a:off x="7150000" y="350000"/>
-            <a:ext cx="1450000" cy="600000"/>
+            <a:off x="6000000" y="1550000"/>
+            <a:ext cx="5350000" cy="4400000"/>
           </a:xfrm>
           <a:prstGeom prst="rect">
             <a:avLst/>
@@ -3233,14 +3256,14 @@
           <a:noFill/>
         </p:spPr>
         <p:txBody>
-          <a:bodyPr wrap="none">
-            <a:spAutoFit/>
+          <a:bodyPr wrap="square">
+            <a:normAutofit/>
           </a:bodyPr>
           <a:lstStyle/>
           <a:p>
             <a:pPr algn="l"/>
             <a:r>
-              <a:rPr sz="1600">
+              <a:rPr sz="1800">
                 <a:latin typeface="Microsoft YaHei"/>
               </a:rPr>
               <a:t>系统默认内容</a:t>
@@ -3248,16 +3271,34 @@
           </a:p>
         </p:txBody>
       </p:sp>
-      <p:sp>
-        <p:nvSpPr>
-          <p:cNvPr id="7" name="TextBox 6"/>
+    </p:spTree>
+  </p:cSld>
+  <p:clrMapOvr>
+    <a:masterClrMapping/>
+  </p:clrMapOvr>
+</p:sld>
+</file>
+
+<file path=ppt/slides/slide3.xml><?xml version="1.0" encoding="utf-8"?>
+<p:sld xmlns:a="http://schemas.openxmlformats.org/drawingml/2006/main" xmlns:p="http://schemas.openxmlformats.org/presentationml/2006/main" xmlns:r="http://schemas.openxmlformats.org/officeDocument/2006/relationships">
+  <p:cSld>
+    <p:spTree>
+      <p:nvGrpSpPr>
+        <p:cNvPr id="1" name=""/>
+        <p:cNvGrpSpPr/>
+        <p:nvPr/>
+      </p:nvGrpSpPr>
+      <p:grpSpPr/>
+      <p:sp>
+        <p:nvSpPr>
+          <p:cNvPr id="2" name="系统默认TITLE1"/>
           <p:cNvSpPr txBox="1"/>
           <p:nvPr/>
         </p:nvSpPr>
         <p:spPr>
           <a:xfrm>
-            <a:off x="8850000" y="350000"/>
-            <a:ext cx="1450000" cy="600000"/>
+            <a:off x="650000" y="400000"/>
+            <a:ext cx="10800000" cy="850000"/>
           </a:xfrm>
           <a:prstGeom prst="rect">
             <a:avLst/>
@@ -3265,14 +3306,14 @@
           <a:noFill/>
         </p:spPr>
         <p:txBody>
-          <a:bodyPr wrap="none">
-            <a:spAutoFit/>
+          <a:bodyPr wrap="square">
+            <a:normAutofit/>
           </a:bodyPr>
           <a:lstStyle/>
           <a:p>
             <a:pPr algn="l"/>
             <a:r>
-              <a:rPr sz="1600">
+              <a:rPr sz="2800">
                 <a:latin typeface="Microsoft YaHei"/>
               </a:rPr>
               <a:t>系统默认内容</a:t>
@@ -3282,14 +3323,14 @@
       </p:sp>
       <p:sp>
         <p:nvSpPr>
-          <p:cNvPr id="8" name="TextBox 7"/>
+          <p:cNvPr id="3" name="系统默认BODY2"/>
           <p:cNvSpPr txBox="1"/>
           <p:nvPr/>
         </p:nvSpPr>
         <p:spPr>
           <a:xfrm>
-            <a:off x="10550000" y="350000"/>
-            <a:ext cx="1450000" cy="600000"/>
+            <a:off x="750000" y="1550000"/>
+            <a:ext cx="4900000" cy="4000000"/>
           </a:xfrm>
           <a:prstGeom prst="rect">
             <a:avLst/>
@@ -3297,14 +3338,14 @@
           <a:noFill/>
         </p:spPr>
         <p:txBody>
-          <a:bodyPr wrap="none">
-            <a:spAutoFit/>
+          <a:bodyPr wrap="square">
+            <a:normAutofit/>
           </a:bodyPr>
           <a:lstStyle/>
           <a:p>
             <a:pPr algn="l"/>
             <a:r>
-              <a:rPr sz="1600">
+              <a:rPr sz="1800">
                 <a:latin typeface="Microsoft YaHei"/>
               </a:rPr>
               <a:t>系统默认内容</a:t>
@@ -3314,14 +3355,14 @@
       </p:sp>
       <p:sp>
         <p:nvSpPr>
-          <p:cNvPr id="9" name="TextBox 8"/>
+          <p:cNvPr id="4" name="系统默认BULLETS3"/>
           <p:cNvSpPr txBox="1"/>
           <p:nvPr/>
         </p:nvSpPr>
         <p:spPr>
           <a:xfrm>
-            <a:off x="350000" y="1100000"/>
-            <a:ext cx="1450000" cy="600000"/>
+            <a:off x="650000" y="2600000"/>
+            <a:ext cx="2565000" cy="2900000"/>
           </a:xfrm>
           <a:prstGeom prst="rect">
             <a:avLst/>
@@ -3329,14 +3370,14 @@
           <a:noFill/>
         </p:spPr>
         <p:txBody>
-          <a:bodyPr wrap="none">
-            <a:spAutoFit/>
+          <a:bodyPr wrap="square">
+            <a:normAutofit/>
           </a:bodyPr>
           <a:lstStyle/>
           <a:p>
             <a:pPr algn="l"/>
             <a:r>
-              <a:rPr sz="1600">
+              <a:rPr sz="1800">
                 <a:latin typeface="Microsoft YaHei"/>
               </a:rPr>
               <a:t>系统默认内容</a:t>
@@ -3346,14 +3387,14 @@
       </p:sp>
       <p:sp>
         <p:nvSpPr>
-          <p:cNvPr id="10" name="TextBox 9"/>
+          <p:cNvPr id="5" name="系统默认BULLETS4"/>
           <p:cNvSpPr txBox="1"/>
           <p:nvPr/>
         </p:nvSpPr>
         <p:spPr>
           <a:xfrm>
-            <a:off x="2050000" y="1100000"/>
-            <a:ext cx="1450000" cy="600000"/>
+            <a:off x="3395000" y="2600000"/>
+            <a:ext cx="2565000" cy="2900000"/>
           </a:xfrm>
           <a:prstGeom prst="rect">
             <a:avLst/>
@@ -3361,14 +3402,14 @@
           <a:noFill/>
         </p:spPr>
         <p:txBody>
-          <a:bodyPr wrap="none">
-            <a:spAutoFit/>
+          <a:bodyPr wrap="square">
+            <a:normAutofit/>
           </a:bodyPr>
           <a:lstStyle/>
           <a:p>
             <a:pPr algn="l"/>
             <a:r>
-              <a:rPr sz="1600">
+              <a:rPr sz="1800">
                 <a:latin typeface="Microsoft YaHei"/>
               </a:rPr>
               <a:t>系统默认内容</a:t>
@@ -3378,14 +3419,14 @@
       </p:sp>
       <p:sp>
         <p:nvSpPr>
-          <p:cNvPr id="11" name="TextBox 10"/>
+          <p:cNvPr id="6" name="系统默认BULLETS5"/>
           <p:cNvSpPr txBox="1"/>
           <p:nvPr/>
         </p:nvSpPr>
         <p:spPr>
           <a:xfrm>
-            <a:off x="3750000" y="1100000"/>
-            <a:ext cx="1450000" cy="600000"/>
+            <a:off x="6140000" y="2600000"/>
+            <a:ext cx="2565000" cy="2900000"/>
           </a:xfrm>
           <a:prstGeom prst="rect">
             <a:avLst/>
@@ -3393,14 +3434,14 @@
           <a:noFill/>
         </p:spPr>
         <p:txBody>
-          <a:bodyPr wrap="none">
-            <a:spAutoFit/>
+          <a:bodyPr wrap="square">
+            <a:normAutofit/>
           </a:bodyPr>
           <a:lstStyle/>
           <a:p>
             <a:pPr algn="l"/>
             <a:r>
-              <a:rPr sz="1600">
+              <a:rPr sz="1800">
                 <a:latin typeface="Microsoft YaHei"/>
               </a:rPr>
               <a:t>系统默认内容</a:t>
@@ -3410,14 +3451,14 @@
       </p:sp>
       <p:sp>
         <p:nvSpPr>
-          <p:cNvPr id="12" name="TextBox 11"/>
+          <p:cNvPr id="7" name="系统默认BULLETS6"/>
           <p:cNvSpPr txBox="1"/>
           <p:nvPr/>
         </p:nvSpPr>
         <p:spPr>
           <a:xfrm>
-            <a:off x="5450000" y="1100000"/>
-            <a:ext cx="1450000" cy="600000"/>
+            <a:off x="8885000" y="2600000"/>
+            <a:ext cx="2565000" cy="2900000"/>
           </a:xfrm>
           <a:prstGeom prst="rect">
             <a:avLst/>
@@ -3425,14 +3466,14 @@
           <a:noFill/>
         </p:spPr>
         <p:txBody>
-          <a:bodyPr wrap="none">
-            <a:spAutoFit/>
+          <a:bodyPr wrap="square">
+            <a:normAutofit/>
           </a:bodyPr>
           <a:lstStyle/>
           <a:p>
             <a:pPr algn="l"/>
             <a:r>
-              <a:rPr sz="1600">
+              <a:rPr sz="1800">
                 <a:latin typeface="Microsoft YaHei"/>
               </a:rPr>
               <a:t>系统默认内容</a:t>
@@ -3440,16 +3481,34 @@
           </a:p>
         </p:txBody>
       </p:sp>
-      <p:sp>
-        <p:nvSpPr>
-          <p:cNvPr id="13" name="TextBox 12"/>
+    </p:spTree>
+  </p:cSld>
+  <p:clrMapOvr>
+    <a:masterClrMapping/>
+  </p:clrMapOvr>
+</p:sld>
+</file>
+
+<file path=ppt/slides/slide4.xml><?xml version="1.0" encoding="utf-8"?>
+<p:sld xmlns:a="http://schemas.openxmlformats.org/drawingml/2006/main" xmlns:p="http://schemas.openxmlformats.org/presentationml/2006/main" xmlns:r="http://schemas.openxmlformats.org/officeDocument/2006/relationships">
+  <p:cSld>
+    <p:spTree>
+      <p:nvGrpSpPr>
+        <p:cNvPr id="1" name=""/>
+        <p:cNvGrpSpPr/>
+        <p:nvPr/>
+      </p:nvGrpSpPr>
+      <p:grpSpPr/>
+      <p:sp>
+        <p:nvSpPr>
+          <p:cNvPr id="2" name="系统默认TITLE1"/>
           <p:cNvSpPr txBox="1"/>
           <p:nvPr/>
         </p:nvSpPr>
         <p:spPr>
           <a:xfrm>
-            <a:off x="7150000" y="1100000"/>
-            <a:ext cx="1450000" cy="600000"/>
+            <a:off x="650000" y="400000"/>
+            <a:ext cx="10800000" cy="850000"/>
           </a:xfrm>
           <a:prstGeom prst="rect">
             <a:avLst/>
@@ -3457,14 +3516,14 @@
           <a:noFill/>
         </p:spPr>
         <p:txBody>
-          <a:bodyPr wrap="none">
-            <a:spAutoFit/>
+          <a:bodyPr wrap="square">
+            <a:normAutofit/>
           </a:bodyPr>
           <a:lstStyle/>
           <a:p>
             <a:pPr algn="l"/>
             <a:r>
-              <a:rPr sz="1600">
+              <a:rPr sz="2800">
                 <a:latin typeface="Microsoft YaHei"/>
               </a:rPr>
               <a:t>系统默认内容</a:t>
@@ -3474,14 +3533,14 @@
       </p:sp>
       <p:sp>
         <p:nvSpPr>
-          <p:cNvPr id="14" name="TextBox 13"/>
+          <p:cNvPr id="3" name="系统默认BODY2"/>
           <p:cNvSpPr txBox="1"/>
           <p:nvPr/>
         </p:nvSpPr>
         <p:spPr>
           <a:xfrm>
-            <a:off x="8850000" y="1100000"/>
-            <a:ext cx="1450000" cy="600000"/>
+            <a:off x="750000" y="1550000"/>
+            <a:ext cx="4900000" cy="4000000"/>
           </a:xfrm>
           <a:prstGeom prst="rect">
             <a:avLst/>
@@ -3489,14 +3548,14 @@
           <a:noFill/>
         </p:spPr>
         <p:txBody>
-          <a:bodyPr wrap="none">
-            <a:spAutoFit/>
+          <a:bodyPr wrap="square">
+            <a:normAutofit/>
           </a:bodyPr>
           <a:lstStyle/>
           <a:p>
             <a:pPr algn="l"/>
             <a:r>
-              <a:rPr sz="1600">
+              <a:rPr sz="1800">
                 <a:latin typeface="Microsoft YaHei"/>
               </a:rPr>
               <a:t>系统默认内容</a:t>
@@ -3506,14 +3565,14 @@
       </p:sp>
       <p:sp>
         <p:nvSpPr>
-          <p:cNvPr id="15" name="TextBox 14"/>
+          <p:cNvPr id="4" name="系统默认BULLETS3"/>
           <p:cNvSpPr txBox="1"/>
           <p:nvPr/>
         </p:nvSpPr>
         <p:spPr>
           <a:xfrm>
-            <a:off x="10550000" y="1100000"/>
-            <a:ext cx="1450000" cy="600000"/>
+            <a:off x="650000" y="2600000"/>
+            <a:ext cx="3480000" cy="2900000"/>
           </a:xfrm>
           <a:prstGeom prst="rect">
             <a:avLst/>
@@ -3521,14 +3580,14 @@
           <a:noFill/>
         </p:spPr>
         <p:txBody>
-          <a:bodyPr wrap="none">
-            <a:spAutoFit/>
+          <a:bodyPr wrap="square">
+            <a:normAutofit/>
           </a:bodyPr>
           <a:lstStyle/>
           <a:p>
             <a:pPr algn="l"/>
             <a:r>
-              <a:rPr sz="1600">
+              <a:rPr sz="1800">
                 <a:latin typeface="Microsoft YaHei"/>
               </a:rPr>
               <a:t>系统默认内容</a:t>
@@ -3538,14 +3597,14 @@
       </p:sp>
       <p:sp>
         <p:nvSpPr>
-          <p:cNvPr id="16" name="TextBox 15"/>
+          <p:cNvPr id="5" name="系统默认BULLETS4"/>
           <p:cNvSpPr txBox="1"/>
           <p:nvPr/>
         </p:nvSpPr>
         <p:spPr>
           <a:xfrm>
-            <a:off x="350000" y="1850000"/>
-            <a:ext cx="1450000" cy="600000"/>
+            <a:off x="4310000" y="2600000"/>
+            <a:ext cx="3480000" cy="2900000"/>
           </a:xfrm>
           <a:prstGeom prst="rect">
             <a:avLst/>
@@ -3553,14 +3612,14 @@
           <a:noFill/>
         </p:spPr>
         <p:txBody>
-          <a:bodyPr wrap="none">
-            <a:spAutoFit/>
+          <a:bodyPr wrap="square">
+            <a:normAutofit/>
           </a:bodyPr>
           <a:lstStyle/>
           <a:p>
             <a:pPr algn="l"/>
             <a:r>
-              <a:rPr sz="1600">
+              <a:rPr sz="1800">
                 <a:latin typeface="Microsoft YaHei"/>
               </a:rPr>
               <a:t>系统默认内容</a:t>
@@ -3570,14 +3629,14 @@
       </p:sp>
       <p:sp>
         <p:nvSpPr>
-          <p:cNvPr id="17" name="TextBox 16"/>
+          <p:cNvPr id="6" name="系统默认BULLETS5"/>
           <p:cNvSpPr txBox="1"/>
           <p:nvPr/>
         </p:nvSpPr>
         <p:spPr>
           <a:xfrm>
-            <a:off x="2050000" y="1850000"/>
-            <a:ext cx="1450000" cy="600000"/>
+            <a:off x="7970000" y="2600000"/>
+            <a:ext cx="3480000" cy="2900000"/>
           </a:xfrm>
           <a:prstGeom prst="rect">
             <a:avLst/>
@@ -3585,14 +3644,14 @@
           <a:noFill/>
         </p:spPr>
         <p:txBody>
-          <a:bodyPr wrap="none">
-            <a:spAutoFit/>
+          <a:bodyPr wrap="square">
+            <a:normAutofit/>
           </a:bodyPr>
           <a:lstStyle/>
           <a:p>
             <a:pPr algn="l"/>
             <a:r>
-              <a:rPr sz="1600">
+              <a:rPr sz="1800">
                 <a:latin typeface="Microsoft YaHei"/>
               </a:rPr>
               <a:t>系统默认内容</a:t>
@@ -3602,14 +3661,14 @@
       </p:sp>
       <p:sp>
         <p:nvSpPr>
-          <p:cNvPr id="18" name="TextBox 17"/>
+          <p:cNvPr id="7" name="系统默认BULLETS6"/>
           <p:cNvSpPr txBox="1"/>
           <p:nvPr/>
         </p:nvSpPr>
         <p:spPr>
           <a:xfrm>
-            <a:off x="3750000" y="1850000"/>
-            <a:ext cx="1450000" cy="600000"/>
+            <a:off x="7970000" y="2600000"/>
+            <a:ext cx="3480000" cy="2900000"/>
           </a:xfrm>
           <a:prstGeom prst="rect">
             <a:avLst/>
@@ -3617,14 +3676,14 @@
           <a:noFill/>
         </p:spPr>
         <p:txBody>
-          <a:bodyPr wrap="none">
-            <a:spAutoFit/>
+          <a:bodyPr wrap="square">
+            <a:normAutofit/>
           </a:bodyPr>
           <a:lstStyle/>
           <a:p>
             <a:pPr algn="l"/>
             <a:r>
-              <a:rPr sz="1600">
+              <a:rPr sz="1800">
                 <a:latin typeface="Microsoft YaHei"/>
               </a:rPr>
               <a:t>系统默认内容</a:t>
@@ -3632,16 +3691,34 @@
           </a:p>
         </p:txBody>
       </p:sp>
-      <p:sp>
-        <p:nvSpPr>
-          <p:cNvPr id="19" name="TextBox 18"/>
+    </p:spTree>
+  </p:cSld>
+  <p:clrMapOvr>
+    <a:masterClrMapping/>
+  </p:clrMapOvr>
+</p:sld>
+</file>
+
+<file path=ppt/slides/slide5.xml><?xml version="1.0" encoding="utf-8"?>
+<p:sld xmlns:a="http://schemas.openxmlformats.org/drawingml/2006/main" xmlns:p="http://schemas.openxmlformats.org/presentationml/2006/main" xmlns:r="http://schemas.openxmlformats.org/officeDocument/2006/relationships">
+  <p:cSld>
+    <p:spTree>
+      <p:nvGrpSpPr>
+        <p:cNvPr id="1" name=""/>
+        <p:cNvGrpSpPr/>
+        <p:nvPr/>
+      </p:nvGrpSpPr>
+      <p:grpSpPr/>
+      <p:sp>
+        <p:nvSpPr>
+          <p:cNvPr id="2" name="系统默认TITLE1"/>
           <p:cNvSpPr txBox="1"/>
           <p:nvPr/>
         </p:nvSpPr>
         <p:spPr>
           <a:xfrm>
-            <a:off x="5450000" y="1850000"/>
-            <a:ext cx="1450000" cy="600000"/>
+            <a:off x="650000" y="400000"/>
+            <a:ext cx="10800000" cy="850000"/>
           </a:xfrm>
           <a:prstGeom prst="rect">
             <a:avLst/>
@@ -3649,14 +3726,14 @@
           <a:noFill/>
         </p:spPr>
         <p:txBody>
-          <a:bodyPr wrap="none">
-            <a:spAutoFit/>
+          <a:bodyPr wrap="square">
+            <a:normAutofit/>
           </a:bodyPr>
           <a:lstStyle/>
           <a:p>
             <a:pPr algn="l"/>
             <a:r>
-              <a:rPr sz="1600">
+              <a:rPr sz="2800">
                 <a:latin typeface="Microsoft YaHei"/>
               </a:rPr>
               <a:t>系统默认内容</a:t>
@@ -3666,14 +3743,14 @@
       </p:sp>
       <p:sp>
         <p:nvSpPr>
-          <p:cNvPr id="20" name="TextBox 19"/>
+          <p:cNvPr id="3" name="系统默认BULLETS2"/>
           <p:cNvSpPr txBox="1"/>
           <p:nvPr/>
         </p:nvSpPr>
         <p:spPr>
           <a:xfrm>
-            <a:off x="7150000" y="1850000"/>
-            <a:ext cx="1450000" cy="600000"/>
+            <a:off x="650000" y="2600000"/>
+            <a:ext cx="2565000" cy="2900000"/>
           </a:xfrm>
           <a:prstGeom prst="rect">
             <a:avLst/>
@@ -3681,14 +3758,14 @@
           <a:noFill/>
         </p:spPr>
         <p:txBody>
-          <a:bodyPr wrap="none">
-            <a:spAutoFit/>
+          <a:bodyPr wrap="square">
+            <a:normAutofit/>
           </a:bodyPr>
           <a:lstStyle/>
           <a:p>
             <a:pPr algn="l"/>
             <a:r>
-              <a:rPr sz="1600">
+              <a:rPr sz="1800">
                 <a:latin typeface="Microsoft YaHei"/>
               </a:rPr>
               <a:t>系统默认内容</a:t>
@@ -3698,14 +3775,14 @@
       </p:sp>
       <p:sp>
         <p:nvSpPr>
-          <p:cNvPr id="21" name="TextBox 20"/>
+          <p:cNvPr id="4" name="系统默认BULLETS3"/>
           <p:cNvSpPr txBox="1"/>
           <p:nvPr/>
         </p:nvSpPr>
         <p:spPr>
           <a:xfrm>
-            <a:off x="8850000" y="1850000"/>
-            <a:ext cx="1450000" cy="600000"/>
+            <a:off x="3395000" y="2600000"/>
+            <a:ext cx="2565000" cy="2900000"/>
           </a:xfrm>
           <a:prstGeom prst="rect">
             <a:avLst/>
@@ -3713,14 +3790,14 @@
           <a:noFill/>
         </p:spPr>
         <p:txBody>
-          <a:bodyPr wrap="none">
-            <a:spAutoFit/>
+          <a:bodyPr wrap="square">
+            <a:normAutofit/>
           </a:bodyPr>
           <a:lstStyle/>
           <a:p>
             <a:pPr algn="l"/>
             <a:r>
-              <a:rPr sz="1600">
+              <a:rPr sz="1800">
                 <a:latin typeface="Microsoft YaHei"/>
               </a:rPr>
               <a:t>系统默认内容</a:t>
@@ -3730,14 +3807,14 @@
       </p:sp>
       <p:sp>
         <p:nvSpPr>
-          <p:cNvPr id="22" name="TextBox 21"/>
+          <p:cNvPr id="5" name="系统默认BULLETS4"/>
           <p:cNvSpPr txBox="1"/>
           <p:nvPr/>
         </p:nvSpPr>
         <p:spPr>
           <a:xfrm>
-            <a:off x="10550000" y="1850000"/>
-            <a:ext cx="1450000" cy="600000"/>
+            <a:off x="6140000" y="2600000"/>
+            <a:ext cx="2565000" cy="2900000"/>
           </a:xfrm>
           <a:prstGeom prst="rect">
             <a:avLst/>
@@ -3745,14 +3822,14 @@
           <a:noFill/>
         </p:spPr>
         <p:txBody>
-          <a:bodyPr wrap="none">
-            <a:spAutoFit/>
+          <a:bodyPr wrap="square">
+            <a:normAutofit/>
           </a:bodyPr>
           <a:lstStyle/>
           <a:p>
             <a:pPr algn="l"/>
             <a:r>
-              <a:rPr sz="1600">
+              <a:rPr sz="1800">
                 <a:latin typeface="Microsoft YaHei"/>
               </a:rPr>
               <a:t>系统默认内容</a:t>
@@ -3762,14 +3839,14 @@
       </p:sp>
       <p:sp>
         <p:nvSpPr>
-          <p:cNvPr id="23" name="TextBox 22"/>
+          <p:cNvPr id="6" name="系统默认BULLETS5"/>
           <p:cNvSpPr txBox="1"/>
           <p:nvPr/>
         </p:nvSpPr>
         <p:spPr>
           <a:xfrm>
-            <a:off x="350000" y="2600000"/>
-            <a:ext cx="1450000" cy="600000"/>
+            <a:off x="8885000" y="2600000"/>
+            <a:ext cx="2565000" cy="2900000"/>
           </a:xfrm>
           <a:prstGeom prst="rect">
             <a:avLst/>
@@ -3777,14 +3854,14 @@
           <a:noFill/>
         </p:spPr>
         <p:txBody>
-          <a:bodyPr wrap="none">
-            <a:spAutoFit/>
+          <a:bodyPr wrap="square">
+            <a:normAutofit/>
           </a:bodyPr>
           <a:lstStyle/>
           <a:p>
             <a:pPr algn="l"/>
             <a:r>
-              <a:rPr sz="1600">
+              <a:rPr sz="1800">
                 <a:latin typeface="Microsoft YaHei"/>
               </a:rPr>
               <a:t>系统默认内容</a:t>
@@ -3792,16 +3869,34 @@
           </a:p>
         </p:txBody>
       </p:sp>
-      <p:sp>
-        <p:nvSpPr>
-          <p:cNvPr id="24" name="TextBox 23"/>
+    </p:spTree>
+  </p:cSld>
+  <p:clrMapOvr>
+    <a:masterClrMapping/>
+  </p:clrMapOvr>
+</p:sld>
+</file>
+
+<file path=ppt/slides/slide6.xml><?xml version="1.0" encoding="utf-8"?>
+<p:sld xmlns:a="http://schemas.openxmlformats.org/drawingml/2006/main" xmlns:p="http://schemas.openxmlformats.org/presentationml/2006/main" xmlns:r="http://schemas.openxmlformats.org/officeDocument/2006/relationships">
+  <p:cSld>
+    <p:spTree>
+      <p:nvGrpSpPr>
+        <p:cNvPr id="1" name=""/>
+        <p:cNvGrpSpPr/>
+        <p:nvPr/>
+      </p:nvGrpSpPr>
+      <p:grpSpPr/>
+      <p:sp>
+        <p:nvSpPr>
+          <p:cNvPr id="2" name="系统默认TITLE1"/>
           <p:cNvSpPr txBox="1"/>
           <p:nvPr/>
         </p:nvSpPr>
         <p:spPr>
           <a:xfrm>
-            <a:off x="2050000" y="2600000"/>
-            <a:ext cx="1450000" cy="600000"/>
+            <a:off x="650000" y="400000"/>
+            <a:ext cx="10800000" cy="850000"/>
           </a:xfrm>
           <a:prstGeom prst="rect">
             <a:avLst/>
@@ -3809,14 +3904,14 @@
           <a:noFill/>
         </p:spPr>
         <p:txBody>
-          <a:bodyPr wrap="none">
-            <a:spAutoFit/>
+          <a:bodyPr wrap="square">
+            <a:normAutofit/>
           </a:bodyPr>
           <a:lstStyle/>
           <a:p>
             <a:pPr algn="l"/>
             <a:r>
-              <a:rPr sz="1600">
+              <a:rPr sz="2800">
                 <a:latin typeface="Microsoft YaHei"/>
               </a:rPr>
               <a:t>系统默认内容</a:t>
@@ -3826,14 +3921,14 @@
       </p:sp>
       <p:sp>
         <p:nvSpPr>
-          <p:cNvPr id="25" name="TextBox 24"/>
+          <p:cNvPr id="3" name="系统默认BULLETS2"/>
           <p:cNvSpPr txBox="1"/>
           <p:nvPr/>
         </p:nvSpPr>
         <p:spPr>
           <a:xfrm>
-            <a:off x="3750000" y="2600000"/>
-            <a:ext cx="1450000" cy="600000"/>
+            <a:off x="650000" y="2600000"/>
+            <a:ext cx="3480000" cy="2900000"/>
           </a:xfrm>
           <a:prstGeom prst="rect">
             <a:avLst/>
@@ -3841,14 +3936,14 @@
           <a:noFill/>
         </p:spPr>
         <p:txBody>
-          <a:bodyPr wrap="none">
-            <a:spAutoFit/>
+          <a:bodyPr wrap="square">
+            <a:normAutofit/>
           </a:bodyPr>
           <a:lstStyle/>
           <a:p>
             <a:pPr algn="l"/>
             <a:r>
-              <a:rPr sz="1600">
+              <a:rPr sz="1800">
                 <a:latin typeface="Microsoft YaHei"/>
               </a:rPr>
               <a:t>系统默认内容</a:t>
@@ -3858,14 +3953,14 @@
       </p:sp>
       <p:sp>
         <p:nvSpPr>
-          <p:cNvPr id="26" name="TextBox 25"/>
+          <p:cNvPr id="4" name="系统默认BULLETS3"/>
           <p:cNvSpPr txBox="1"/>
           <p:nvPr/>
         </p:nvSpPr>
         <p:spPr>
           <a:xfrm>
-            <a:off x="5450000" y="2600000"/>
-            <a:ext cx="1450000" cy="600000"/>
+            <a:off x="4310000" y="2600000"/>
+            <a:ext cx="3480000" cy="2900000"/>
           </a:xfrm>
           <a:prstGeom prst="rect">
             <a:avLst/>
@@ -3873,14 +3968,14 @@
           <a:noFill/>
         </p:spPr>
         <p:txBody>
-          <a:bodyPr wrap="none">
-            <a:spAutoFit/>
+          <a:bodyPr wrap="square">
+            <a:normAutofit/>
           </a:bodyPr>
           <a:lstStyle/>
           <a:p>
             <a:pPr algn="l"/>
             <a:r>
-              <a:rPr sz="1600">
+              <a:rPr sz="1800">
                 <a:latin typeface="Microsoft YaHei"/>
               </a:rPr>
               <a:t>系统默认内容</a:t>
@@ -3890,14 +3985,14 @@
       </p:sp>
       <p:sp>
         <p:nvSpPr>
-          <p:cNvPr id="27" name="TextBox 26"/>
+          <p:cNvPr id="5" name="系统默认BULLETS4"/>
           <p:cNvSpPr txBox="1"/>
           <p:nvPr/>
         </p:nvSpPr>
         <p:spPr>
           <a:xfrm>
-            <a:off x="7150000" y="2600000"/>
-            <a:ext cx="1450000" cy="600000"/>
+            <a:off x="7970000" y="2600000"/>
+            <a:ext cx="3480000" cy="2900000"/>
           </a:xfrm>
           <a:prstGeom prst="rect">
             <a:avLst/>
@@ -3905,974 +4000,14 @@
           <a:noFill/>
         </p:spPr>
         <p:txBody>
-          <a:bodyPr wrap="none">
-            <a:spAutoFit/>
+          <a:bodyPr wrap="square">
+            <a:normAutofit/>
           </a:bodyPr>
           <a:lstStyle/>
           <a:p>
             <a:pPr algn="l"/>
             <a:r>
-              <a:rPr sz="1600">
-                <a:latin typeface="Microsoft YaHei"/>
-              </a:rPr>
-              <a:t>系统默认内容</a:t>
-            </a:r>
-          </a:p>
-        </p:txBody>
-      </p:sp>
-      <p:sp>
-        <p:nvSpPr>
-          <p:cNvPr id="28" name="TextBox 27"/>
-          <p:cNvSpPr txBox="1"/>
-          <p:nvPr/>
-        </p:nvSpPr>
-        <p:spPr>
-          <a:xfrm>
-            <a:off x="8850000" y="2600000"/>
-            <a:ext cx="1450000" cy="600000"/>
-          </a:xfrm>
-          <a:prstGeom prst="rect">
-            <a:avLst/>
-          </a:prstGeom>
-          <a:noFill/>
-        </p:spPr>
-        <p:txBody>
-          <a:bodyPr wrap="none">
-            <a:spAutoFit/>
-          </a:bodyPr>
-          <a:lstStyle/>
-          <a:p>
-            <a:pPr algn="l"/>
-            <a:r>
-              <a:rPr sz="1600">
-                <a:latin typeface="Microsoft YaHei"/>
-              </a:rPr>
-              <a:t>系统默认内容</a:t>
-            </a:r>
-          </a:p>
-        </p:txBody>
-      </p:sp>
-      <p:sp>
-        <p:nvSpPr>
-          <p:cNvPr id="29" name="TextBox 28"/>
-          <p:cNvSpPr txBox="1"/>
-          <p:nvPr/>
-        </p:nvSpPr>
-        <p:spPr>
-          <a:xfrm>
-            <a:off x="10550000" y="2600000"/>
-            <a:ext cx="1450000" cy="600000"/>
-          </a:xfrm>
-          <a:prstGeom prst="rect">
-            <a:avLst/>
-          </a:prstGeom>
-          <a:noFill/>
-        </p:spPr>
-        <p:txBody>
-          <a:bodyPr wrap="none">
-            <a:spAutoFit/>
-          </a:bodyPr>
-          <a:lstStyle/>
-          <a:p>
-            <a:pPr algn="l"/>
-            <a:r>
-              <a:rPr sz="1600">
-                <a:latin typeface="Microsoft YaHei"/>
-              </a:rPr>
-              <a:t>系统默认内容</a:t>
-            </a:r>
-          </a:p>
-        </p:txBody>
-      </p:sp>
-      <p:sp>
-        <p:nvSpPr>
-          <p:cNvPr id="30" name="TextBox 29"/>
-          <p:cNvSpPr txBox="1"/>
-          <p:nvPr/>
-        </p:nvSpPr>
-        <p:spPr>
-          <a:xfrm>
-            <a:off x="350000" y="3350000"/>
-            <a:ext cx="1450000" cy="600000"/>
-          </a:xfrm>
-          <a:prstGeom prst="rect">
-            <a:avLst/>
-          </a:prstGeom>
-          <a:noFill/>
-        </p:spPr>
-        <p:txBody>
-          <a:bodyPr wrap="none">
-            <a:spAutoFit/>
-          </a:bodyPr>
-          <a:lstStyle/>
-          <a:p>
-            <a:pPr algn="l"/>
-            <a:r>
-              <a:rPr sz="1600">
-                <a:latin typeface="Microsoft YaHei"/>
-              </a:rPr>
-              <a:t>系统默认内容</a:t>
-            </a:r>
-          </a:p>
-        </p:txBody>
-      </p:sp>
-      <p:sp>
-        <p:nvSpPr>
-          <p:cNvPr id="31" name="TextBox 30"/>
-          <p:cNvSpPr txBox="1"/>
-          <p:nvPr/>
-        </p:nvSpPr>
-        <p:spPr>
-          <a:xfrm>
-            <a:off x="2050000" y="3350000"/>
-            <a:ext cx="1450000" cy="600000"/>
-          </a:xfrm>
-          <a:prstGeom prst="rect">
-            <a:avLst/>
-          </a:prstGeom>
-          <a:noFill/>
-        </p:spPr>
-        <p:txBody>
-          <a:bodyPr wrap="none">
-            <a:spAutoFit/>
-          </a:bodyPr>
-          <a:lstStyle/>
-          <a:p>
-            <a:pPr algn="l"/>
-            <a:r>
-              <a:rPr sz="1600">
-                <a:latin typeface="Microsoft YaHei"/>
-              </a:rPr>
-              <a:t>系统默认内容</a:t>
-            </a:r>
-          </a:p>
-        </p:txBody>
-      </p:sp>
-      <p:sp>
-        <p:nvSpPr>
-          <p:cNvPr id="32" name="TextBox 31"/>
-          <p:cNvSpPr txBox="1"/>
-          <p:nvPr/>
-        </p:nvSpPr>
-        <p:spPr>
-          <a:xfrm>
-            <a:off x="3750000" y="3350000"/>
-            <a:ext cx="1450000" cy="600000"/>
-          </a:xfrm>
-          <a:prstGeom prst="rect">
-            <a:avLst/>
-          </a:prstGeom>
-          <a:noFill/>
-        </p:spPr>
-        <p:txBody>
-          <a:bodyPr wrap="none">
-            <a:spAutoFit/>
-          </a:bodyPr>
-          <a:lstStyle/>
-          <a:p>
-            <a:pPr algn="l"/>
-            <a:r>
-              <a:rPr sz="1600">
-                <a:latin typeface="Microsoft YaHei"/>
-              </a:rPr>
-              <a:t>系统默认内容</a:t>
-            </a:r>
-          </a:p>
-        </p:txBody>
-      </p:sp>
-      <p:sp>
-        <p:nvSpPr>
-          <p:cNvPr id="33" name="TextBox 32"/>
-          <p:cNvSpPr txBox="1"/>
-          <p:nvPr/>
-        </p:nvSpPr>
-        <p:spPr>
-          <a:xfrm>
-            <a:off x="5450000" y="3350000"/>
-            <a:ext cx="1450000" cy="600000"/>
-          </a:xfrm>
-          <a:prstGeom prst="rect">
-            <a:avLst/>
-          </a:prstGeom>
-          <a:noFill/>
-        </p:spPr>
-        <p:txBody>
-          <a:bodyPr wrap="none">
-            <a:spAutoFit/>
-          </a:bodyPr>
-          <a:lstStyle/>
-          <a:p>
-            <a:pPr algn="l"/>
-            <a:r>
-              <a:rPr sz="1600">
-                <a:latin typeface="Microsoft YaHei"/>
-              </a:rPr>
-              <a:t>系统默认内容</a:t>
-            </a:r>
-          </a:p>
-        </p:txBody>
-      </p:sp>
-      <p:sp>
-        <p:nvSpPr>
-          <p:cNvPr id="34" name="TextBox 33"/>
-          <p:cNvSpPr txBox="1"/>
-          <p:nvPr/>
-        </p:nvSpPr>
-        <p:spPr>
-          <a:xfrm>
-            <a:off x="7150000" y="3350000"/>
-            <a:ext cx="1450000" cy="600000"/>
-          </a:xfrm>
-          <a:prstGeom prst="rect">
-            <a:avLst/>
-          </a:prstGeom>
-          <a:noFill/>
-        </p:spPr>
-        <p:txBody>
-          <a:bodyPr wrap="none">
-            <a:spAutoFit/>
-          </a:bodyPr>
-          <a:lstStyle/>
-          <a:p>
-            <a:pPr algn="l"/>
-            <a:r>
-              <a:rPr sz="1600">
-                <a:latin typeface="Microsoft YaHei"/>
-              </a:rPr>
-              <a:t>系统默认内容</a:t>
-            </a:r>
-          </a:p>
-        </p:txBody>
-      </p:sp>
-      <p:sp>
-        <p:nvSpPr>
-          <p:cNvPr id="35" name="TextBox 34"/>
-          <p:cNvSpPr txBox="1"/>
-          <p:nvPr/>
-        </p:nvSpPr>
-        <p:spPr>
-          <a:xfrm>
-            <a:off x="8850000" y="3350000"/>
-            <a:ext cx="1450000" cy="600000"/>
-          </a:xfrm>
-          <a:prstGeom prst="rect">
-            <a:avLst/>
-          </a:prstGeom>
-          <a:noFill/>
-        </p:spPr>
-        <p:txBody>
-          <a:bodyPr wrap="none">
-            <a:spAutoFit/>
-          </a:bodyPr>
-          <a:lstStyle/>
-          <a:p>
-            <a:pPr algn="l"/>
-            <a:r>
-              <a:rPr sz="1600">
-                <a:latin typeface="Microsoft YaHei"/>
-              </a:rPr>
-              <a:t>系统默认内容</a:t>
-            </a:r>
-          </a:p>
-        </p:txBody>
-      </p:sp>
-      <p:sp>
-        <p:nvSpPr>
-          <p:cNvPr id="36" name="TextBox 35"/>
-          <p:cNvSpPr txBox="1"/>
-          <p:nvPr/>
-        </p:nvSpPr>
-        <p:spPr>
-          <a:xfrm>
-            <a:off x="10550000" y="3350000"/>
-            <a:ext cx="1450000" cy="600000"/>
-          </a:xfrm>
-          <a:prstGeom prst="rect">
-            <a:avLst/>
-          </a:prstGeom>
-          <a:noFill/>
-        </p:spPr>
-        <p:txBody>
-          <a:bodyPr wrap="none">
-            <a:spAutoFit/>
-          </a:bodyPr>
-          <a:lstStyle/>
-          <a:p>
-            <a:pPr algn="l"/>
-            <a:r>
-              <a:rPr sz="1600">
-                <a:latin typeface="Microsoft YaHei"/>
-              </a:rPr>
-              <a:t>系统默认内容</a:t>
-            </a:r>
-          </a:p>
-        </p:txBody>
-      </p:sp>
-      <p:sp>
-        <p:nvSpPr>
-          <p:cNvPr id="37" name="TextBox 36"/>
-          <p:cNvSpPr txBox="1"/>
-          <p:nvPr/>
-        </p:nvSpPr>
-        <p:spPr>
-          <a:xfrm>
-            <a:off x="350000" y="4100000"/>
-            <a:ext cx="1450000" cy="600000"/>
-          </a:xfrm>
-          <a:prstGeom prst="rect">
-            <a:avLst/>
-          </a:prstGeom>
-          <a:noFill/>
-        </p:spPr>
-        <p:txBody>
-          <a:bodyPr wrap="none">
-            <a:spAutoFit/>
-          </a:bodyPr>
-          <a:lstStyle/>
-          <a:p>
-            <a:pPr algn="l"/>
-            <a:r>
-              <a:rPr sz="1600">
-                <a:latin typeface="Microsoft YaHei"/>
-              </a:rPr>
-              <a:t>系统默认内容</a:t>
-            </a:r>
-          </a:p>
-        </p:txBody>
-      </p:sp>
-      <p:sp>
-        <p:nvSpPr>
-          <p:cNvPr id="38" name="TextBox 37"/>
-          <p:cNvSpPr txBox="1"/>
-          <p:nvPr/>
-        </p:nvSpPr>
-        <p:spPr>
-          <a:xfrm>
-            <a:off x="2050000" y="4100000"/>
-            <a:ext cx="1450000" cy="600000"/>
-          </a:xfrm>
-          <a:prstGeom prst="rect">
-            <a:avLst/>
-          </a:prstGeom>
-          <a:noFill/>
-        </p:spPr>
-        <p:txBody>
-          <a:bodyPr wrap="none">
-            <a:spAutoFit/>
-          </a:bodyPr>
-          <a:lstStyle/>
-          <a:p>
-            <a:pPr algn="l"/>
-            <a:r>
-              <a:rPr sz="1600">
-                <a:latin typeface="Microsoft YaHei"/>
-              </a:rPr>
-              <a:t>系统默认内容</a:t>
-            </a:r>
-          </a:p>
-        </p:txBody>
-      </p:sp>
-      <p:sp>
-        <p:nvSpPr>
-          <p:cNvPr id="39" name="TextBox 38"/>
-          <p:cNvSpPr txBox="1"/>
-          <p:nvPr/>
-        </p:nvSpPr>
-        <p:spPr>
-          <a:xfrm>
-            <a:off x="3750000" y="4100000"/>
-            <a:ext cx="1450000" cy="600000"/>
-          </a:xfrm>
-          <a:prstGeom prst="rect">
-            <a:avLst/>
-          </a:prstGeom>
-          <a:noFill/>
-        </p:spPr>
-        <p:txBody>
-          <a:bodyPr wrap="none">
-            <a:spAutoFit/>
-          </a:bodyPr>
-          <a:lstStyle/>
-          <a:p>
-            <a:pPr algn="l"/>
-            <a:r>
-              <a:rPr sz="1600">
-                <a:latin typeface="Microsoft YaHei"/>
-              </a:rPr>
-              <a:t>系统默认内容</a:t>
-            </a:r>
-          </a:p>
-        </p:txBody>
-      </p:sp>
-      <p:sp>
-        <p:nvSpPr>
-          <p:cNvPr id="40" name="TextBox 39"/>
-          <p:cNvSpPr txBox="1"/>
-          <p:nvPr/>
-        </p:nvSpPr>
-        <p:spPr>
-          <a:xfrm>
-            <a:off x="5450000" y="4100000"/>
-            <a:ext cx="1450000" cy="600000"/>
-          </a:xfrm>
-          <a:prstGeom prst="rect">
-            <a:avLst/>
-          </a:prstGeom>
-          <a:noFill/>
-        </p:spPr>
-        <p:txBody>
-          <a:bodyPr wrap="none">
-            <a:spAutoFit/>
-          </a:bodyPr>
-          <a:lstStyle/>
-          <a:p>
-            <a:pPr algn="l"/>
-            <a:r>
-              <a:rPr sz="1600">
-                <a:latin typeface="Microsoft YaHei"/>
-              </a:rPr>
-              <a:t>系统默认内容</a:t>
-            </a:r>
-          </a:p>
-        </p:txBody>
-      </p:sp>
-      <p:sp>
-        <p:nvSpPr>
-          <p:cNvPr id="41" name="TextBox 40"/>
-          <p:cNvSpPr txBox="1"/>
-          <p:nvPr/>
-        </p:nvSpPr>
-        <p:spPr>
-          <a:xfrm>
-            <a:off x="7150000" y="4100000"/>
-            <a:ext cx="1450000" cy="600000"/>
-          </a:xfrm>
-          <a:prstGeom prst="rect">
-            <a:avLst/>
-          </a:prstGeom>
-          <a:noFill/>
-        </p:spPr>
-        <p:txBody>
-          <a:bodyPr wrap="none">
-            <a:spAutoFit/>
-          </a:bodyPr>
-          <a:lstStyle/>
-          <a:p>
-            <a:pPr algn="l"/>
-            <a:r>
-              <a:rPr sz="1600">
-                <a:latin typeface="Microsoft YaHei"/>
-              </a:rPr>
-              <a:t>系统默认内容</a:t>
-            </a:r>
-          </a:p>
-        </p:txBody>
-      </p:sp>
-      <p:sp>
-        <p:nvSpPr>
-          <p:cNvPr id="42" name="TextBox 41"/>
-          <p:cNvSpPr txBox="1"/>
-          <p:nvPr/>
-        </p:nvSpPr>
-        <p:spPr>
-          <a:xfrm>
-            <a:off x="8850000" y="4100000"/>
-            <a:ext cx="1450000" cy="600000"/>
-          </a:xfrm>
-          <a:prstGeom prst="rect">
-            <a:avLst/>
-          </a:prstGeom>
-          <a:noFill/>
-        </p:spPr>
-        <p:txBody>
-          <a:bodyPr wrap="none">
-            <a:spAutoFit/>
-          </a:bodyPr>
-          <a:lstStyle/>
-          <a:p>
-            <a:pPr algn="l"/>
-            <a:r>
-              <a:rPr sz="1600">
-                <a:latin typeface="Microsoft YaHei"/>
-              </a:rPr>
-              <a:t>系统默认内容</a:t>
-            </a:r>
-          </a:p>
-        </p:txBody>
-      </p:sp>
-      <p:sp>
-        <p:nvSpPr>
-          <p:cNvPr id="43" name="TextBox 42"/>
-          <p:cNvSpPr txBox="1"/>
-          <p:nvPr/>
-        </p:nvSpPr>
-        <p:spPr>
-          <a:xfrm>
-            <a:off x="10550000" y="4100000"/>
-            <a:ext cx="1450000" cy="600000"/>
-          </a:xfrm>
-          <a:prstGeom prst="rect">
-            <a:avLst/>
-          </a:prstGeom>
-          <a:noFill/>
-        </p:spPr>
-        <p:txBody>
-          <a:bodyPr wrap="none">
-            <a:spAutoFit/>
-          </a:bodyPr>
-          <a:lstStyle/>
-          <a:p>
-            <a:pPr algn="l"/>
-            <a:r>
-              <a:rPr sz="1600">
-                <a:latin typeface="Microsoft YaHei"/>
-              </a:rPr>
-              <a:t>系统默认内容</a:t>
-            </a:r>
-          </a:p>
-        </p:txBody>
-      </p:sp>
-      <p:sp>
-        <p:nvSpPr>
-          <p:cNvPr id="44" name="TextBox 43"/>
-          <p:cNvSpPr txBox="1"/>
-          <p:nvPr/>
-        </p:nvSpPr>
-        <p:spPr>
-          <a:xfrm>
-            <a:off x="350000" y="4850000"/>
-            <a:ext cx="1450000" cy="600000"/>
-          </a:xfrm>
-          <a:prstGeom prst="rect">
-            <a:avLst/>
-          </a:prstGeom>
-          <a:noFill/>
-        </p:spPr>
-        <p:txBody>
-          <a:bodyPr wrap="none">
-            <a:spAutoFit/>
-          </a:bodyPr>
-          <a:lstStyle/>
-          <a:p>
-            <a:pPr algn="l"/>
-            <a:r>
-              <a:rPr sz="1600">
-                <a:latin typeface="Microsoft YaHei"/>
-              </a:rPr>
-              <a:t>系统默认内容</a:t>
-            </a:r>
-          </a:p>
-        </p:txBody>
-      </p:sp>
-      <p:sp>
-        <p:nvSpPr>
-          <p:cNvPr id="45" name="TextBox 44"/>
-          <p:cNvSpPr txBox="1"/>
-          <p:nvPr/>
-        </p:nvSpPr>
-        <p:spPr>
-          <a:xfrm>
-            <a:off x="2050000" y="4850000"/>
-            <a:ext cx="1450000" cy="600000"/>
-          </a:xfrm>
-          <a:prstGeom prst="rect">
-            <a:avLst/>
-          </a:prstGeom>
-          <a:noFill/>
-        </p:spPr>
-        <p:txBody>
-          <a:bodyPr wrap="none">
-            <a:spAutoFit/>
-          </a:bodyPr>
-          <a:lstStyle/>
-          <a:p>
-            <a:pPr algn="l"/>
-            <a:r>
-              <a:rPr sz="1600">
-                <a:latin typeface="Microsoft YaHei"/>
-              </a:rPr>
-              <a:t>系统默认内容</a:t>
-            </a:r>
-          </a:p>
-        </p:txBody>
-      </p:sp>
-      <p:sp>
-        <p:nvSpPr>
-          <p:cNvPr id="46" name="TextBox 45"/>
-          <p:cNvSpPr txBox="1"/>
-          <p:nvPr/>
-        </p:nvSpPr>
-        <p:spPr>
-          <a:xfrm>
-            <a:off x="3750000" y="4850000"/>
-            <a:ext cx="1450000" cy="600000"/>
-          </a:xfrm>
-          <a:prstGeom prst="rect">
-            <a:avLst/>
-          </a:prstGeom>
-          <a:noFill/>
-        </p:spPr>
-        <p:txBody>
-          <a:bodyPr wrap="none">
-            <a:spAutoFit/>
-          </a:bodyPr>
-          <a:lstStyle/>
-          <a:p>
-            <a:pPr algn="l"/>
-            <a:r>
-              <a:rPr sz="1600">
-                <a:latin typeface="Microsoft YaHei"/>
-              </a:rPr>
-              <a:t>系统默认内容</a:t>
-            </a:r>
-          </a:p>
-        </p:txBody>
-      </p:sp>
-      <p:sp>
-        <p:nvSpPr>
-          <p:cNvPr id="47" name="TextBox 46"/>
-          <p:cNvSpPr txBox="1"/>
-          <p:nvPr/>
-        </p:nvSpPr>
-        <p:spPr>
-          <a:xfrm>
-            <a:off x="5450000" y="4850000"/>
-            <a:ext cx="1450000" cy="600000"/>
-          </a:xfrm>
-          <a:prstGeom prst="rect">
-            <a:avLst/>
-          </a:prstGeom>
-          <a:noFill/>
-        </p:spPr>
-        <p:txBody>
-          <a:bodyPr wrap="none">
-            <a:spAutoFit/>
-          </a:bodyPr>
-          <a:lstStyle/>
-          <a:p>
-            <a:pPr algn="l"/>
-            <a:r>
-              <a:rPr sz="1600">
-                <a:latin typeface="Microsoft YaHei"/>
-              </a:rPr>
-              <a:t>系统默认内容</a:t>
-            </a:r>
-          </a:p>
-        </p:txBody>
-      </p:sp>
-      <p:sp>
-        <p:nvSpPr>
-          <p:cNvPr id="48" name="TextBox 47"/>
-          <p:cNvSpPr txBox="1"/>
-          <p:nvPr/>
-        </p:nvSpPr>
-        <p:spPr>
-          <a:xfrm>
-            <a:off x="7150000" y="4850000"/>
-            <a:ext cx="1450000" cy="600000"/>
-          </a:xfrm>
-          <a:prstGeom prst="rect">
-            <a:avLst/>
-          </a:prstGeom>
-          <a:noFill/>
-        </p:spPr>
-        <p:txBody>
-          <a:bodyPr wrap="none">
-            <a:spAutoFit/>
-          </a:bodyPr>
-          <a:lstStyle/>
-          <a:p>
-            <a:pPr algn="l"/>
-            <a:r>
-              <a:rPr sz="1600">
-                <a:latin typeface="Microsoft YaHei"/>
-              </a:rPr>
-              <a:t>系统默认内容</a:t>
-            </a:r>
-          </a:p>
-        </p:txBody>
-      </p:sp>
-      <p:sp>
-        <p:nvSpPr>
-          <p:cNvPr id="49" name="TextBox 48"/>
-          <p:cNvSpPr txBox="1"/>
-          <p:nvPr/>
-        </p:nvSpPr>
-        <p:spPr>
-          <a:xfrm>
-            <a:off x="8850000" y="4850000"/>
-            <a:ext cx="1450000" cy="600000"/>
-          </a:xfrm>
-          <a:prstGeom prst="rect">
-            <a:avLst/>
-          </a:prstGeom>
-          <a:noFill/>
-        </p:spPr>
-        <p:txBody>
-          <a:bodyPr wrap="none">
-            <a:spAutoFit/>
-          </a:bodyPr>
-          <a:lstStyle/>
-          <a:p>
-            <a:pPr algn="l"/>
-            <a:r>
-              <a:rPr sz="1600">
-                <a:latin typeface="Microsoft YaHei"/>
-              </a:rPr>
-              <a:t>系统默认内容</a:t>
-            </a:r>
-          </a:p>
-        </p:txBody>
-      </p:sp>
-      <p:sp>
-        <p:nvSpPr>
-          <p:cNvPr id="50" name="TextBox 49"/>
-          <p:cNvSpPr txBox="1"/>
-          <p:nvPr/>
-        </p:nvSpPr>
-        <p:spPr>
-          <a:xfrm>
-            <a:off x="10550000" y="4850000"/>
-            <a:ext cx="1450000" cy="600000"/>
-          </a:xfrm>
-          <a:prstGeom prst="rect">
-            <a:avLst/>
-          </a:prstGeom>
-          <a:noFill/>
-        </p:spPr>
-        <p:txBody>
-          <a:bodyPr wrap="none">
-            <a:spAutoFit/>
-          </a:bodyPr>
-          <a:lstStyle/>
-          <a:p>
-            <a:pPr algn="l"/>
-            <a:r>
-              <a:rPr sz="1600">
-                <a:latin typeface="Microsoft YaHei"/>
-              </a:rPr>
-              <a:t>系统默认内容</a:t>
-            </a:r>
-          </a:p>
-        </p:txBody>
-      </p:sp>
-      <p:sp>
-        <p:nvSpPr>
-          <p:cNvPr id="51" name="TextBox 50"/>
-          <p:cNvSpPr txBox="1"/>
-          <p:nvPr/>
-        </p:nvSpPr>
-        <p:spPr>
-          <a:xfrm>
-            <a:off x="350000" y="5600000"/>
-            <a:ext cx="1450000" cy="600000"/>
-          </a:xfrm>
-          <a:prstGeom prst="rect">
-            <a:avLst/>
-          </a:prstGeom>
-          <a:noFill/>
-        </p:spPr>
-        <p:txBody>
-          <a:bodyPr wrap="none">
-            <a:spAutoFit/>
-          </a:bodyPr>
-          <a:lstStyle/>
-          <a:p>
-            <a:pPr algn="l"/>
-            <a:r>
-              <a:rPr sz="1600">
-                <a:latin typeface="Microsoft YaHei"/>
-              </a:rPr>
-              <a:t>系统默认内容</a:t>
-            </a:r>
-          </a:p>
-        </p:txBody>
-      </p:sp>
-      <p:sp>
-        <p:nvSpPr>
-          <p:cNvPr id="52" name="TextBox 51"/>
-          <p:cNvSpPr txBox="1"/>
-          <p:nvPr/>
-        </p:nvSpPr>
-        <p:spPr>
-          <a:xfrm>
-            <a:off x="2050000" y="5600000"/>
-            <a:ext cx="1450000" cy="600000"/>
-          </a:xfrm>
-          <a:prstGeom prst="rect">
-            <a:avLst/>
-          </a:prstGeom>
-          <a:noFill/>
-        </p:spPr>
-        <p:txBody>
-          <a:bodyPr wrap="none">
-            <a:spAutoFit/>
-          </a:bodyPr>
-          <a:lstStyle/>
-          <a:p>
-            <a:pPr algn="l"/>
-            <a:r>
-              <a:rPr sz="1600">
-                <a:latin typeface="Microsoft YaHei"/>
-              </a:rPr>
-              <a:t>系统默认内容</a:t>
-            </a:r>
-          </a:p>
-        </p:txBody>
-      </p:sp>
-      <p:sp>
-        <p:nvSpPr>
-          <p:cNvPr id="53" name="TextBox 52"/>
-          <p:cNvSpPr txBox="1"/>
-          <p:nvPr/>
-        </p:nvSpPr>
-        <p:spPr>
-          <a:xfrm>
-            <a:off x="3750000" y="5600000"/>
-            <a:ext cx="1450000" cy="600000"/>
-          </a:xfrm>
-          <a:prstGeom prst="rect">
-            <a:avLst/>
-          </a:prstGeom>
-          <a:noFill/>
-        </p:spPr>
-        <p:txBody>
-          <a:bodyPr wrap="none">
-            <a:spAutoFit/>
-          </a:bodyPr>
-          <a:lstStyle/>
-          <a:p>
-            <a:pPr algn="l"/>
-            <a:r>
-              <a:rPr sz="1600">
-                <a:latin typeface="Microsoft YaHei"/>
-              </a:rPr>
-              <a:t>系统默认内容</a:t>
-            </a:r>
-          </a:p>
-        </p:txBody>
-      </p:sp>
-      <p:sp>
-        <p:nvSpPr>
-          <p:cNvPr id="54" name="TextBox 53"/>
-          <p:cNvSpPr txBox="1"/>
-          <p:nvPr/>
-        </p:nvSpPr>
-        <p:spPr>
-          <a:xfrm>
-            <a:off x="5450000" y="5600000"/>
-            <a:ext cx="1450000" cy="600000"/>
-          </a:xfrm>
-          <a:prstGeom prst="rect">
-            <a:avLst/>
-          </a:prstGeom>
-          <a:noFill/>
-        </p:spPr>
-        <p:txBody>
-          <a:bodyPr wrap="none">
-            <a:spAutoFit/>
-          </a:bodyPr>
-          <a:lstStyle/>
-          <a:p>
-            <a:pPr algn="l"/>
-            <a:r>
-              <a:rPr sz="1600">
-                <a:latin typeface="Microsoft YaHei"/>
-              </a:rPr>
-              <a:t>系统默认内容</a:t>
-            </a:r>
-          </a:p>
-        </p:txBody>
-      </p:sp>
-      <p:sp>
-        <p:nvSpPr>
-          <p:cNvPr id="55" name="TextBox 54"/>
-          <p:cNvSpPr txBox="1"/>
-          <p:nvPr/>
-        </p:nvSpPr>
-        <p:spPr>
-          <a:xfrm>
-            <a:off x="7150000" y="5600000"/>
-            <a:ext cx="1450000" cy="600000"/>
-          </a:xfrm>
-          <a:prstGeom prst="rect">
-            <a:avLst/>
-          </a:prstGeom>
-          <a:noFill/>
-        </p:spPr>
-        <p:txBody>
-          <a:bodyPr wrap="none">
-            <a:spAutoFit/>
-          </a:bodyPr>
-          <a:lstStyle/>
-          <a:p>
-            <a:pPr algn="l"/>
-            <a:r>
-              <a:rPr sz="1600">
-                <a:latin typeface="Microsoft YaHei"/>
-              </a:rPr>
-              <a:t>系统默认内容</a:t>
-            </a:r>
-          </a:p>
-        </p:txBody>
-      </p:sp>
-      <p:sp>
-        <p:nvSpPr>
-          <p:cNvPr id="56" name="TextBox 55"/>
-          <p:cNvSpPr txBox="1"/>
-          <p:nvPr/>
-        </p:nvSpPr>
-        <p:spPr>
-          <a:xfrm>
-            <a:off x="8850000" y="5600000"/>
-            <a:ext cx="1450000" cy="600000"/>
-          </a:xfrm>
-          <a:prstGeom prst="rect">
-            <a:avLst/>
-          </a:prstGeom>
-          <a:noFill/>
-        </p:spPr>
-        <p:txBody>
-          <a:bodyPr wrap="none">
-            <a:spAutoFit/>
-          </a:bodyPr>
-          <a:lstStyle/>
-          <a:p>
-            <a:pPr algn="l"/>
-            <a:r>
-              <a:rPr sz="1600">
-                <a:latin typeface="Microsoft YaHei"/>
-              </a:rPr>
-              <a:t>系统默认内容</a:t>
-            </a:r>
-          </a:p>
-        </p:txBody>
-      </p:sp>
-      <p:sp>
-        <p:nvSpPr>
-          <p:cNvPr id="57" name="TextBox 56"/>
-          <p:cNvSpPr txBox="1"/>
-          <p:nvPr/>
-        </p:nvSpPr>
-        <p:spPr>
-          <a:xfrm>
-            <a:off x="10550000" y="5600000"/>
-            <a:ext cx="1450000" cy="600000"/>
-          </a:xfrm>
-          <a:prstGeom prst="rect">
-            <a:avLst/>
-          </a:prstGeom>
-          <a:noFill/>
-        </p:spPr>
-        <p:txBody>
-          <a:bodyPr wrap="none">
-            <a:spAutoFit/>
-          </a:bodyPr>
-          <a:lstStyle/>
-          <a:p>
-            <a:pPr algn="l"/>
-            <a:r>
-              <a:rPr sz="1600">
+              <a:rPr sz="1800">
                 <a:latin typeface="Microsoft YaHei"/>
               </a:rPr>
               <a:t>系统默认内容</a:t>

</xml_diff>